<commit_message>
Figure 1: static-vs-dynamic obstacle framing + matching description
Re-export pipeline_v2 from the edited PPTX (same exact crop, 1144x436). The figure
now splits obstacle handling honestly: "Static Obstacle Modeling" at the planner
(TeLoGraF plans against a per-cycle sensed snapshot) vs "Dynamic obstacle handling"
at the reactive MPPI tracker (~7 Hz re-optimizes against the LIVE LiDAR-sensed
field -- see tb3_follower._mppi cost term 3). Updated the corresponding poster
description (Fig.1 caption, alt-text, and the sensor-grounded keep-safe paragraph)
to match; trimmed the caption's checks sentence so SS5 stays on page 4 (body <=4pp).
</commit_message>
<xml_diff>
--- a/outputs/paper/pipeline_v2.pptx
+++ b/outputs/paper/pipeline_v2.pptx
@@ -79,11 +79,11 @@
             <a:noAutofit/>
           </a:bodyPr>
           <a:p>
-            <a:endParaRPr b="0" lang="en-US" sz="1800" spc="-1" strike="noStrike">
-              <a:solidFill>
-                <a:srgbClr val="000000"/>
-              </a:solidFill>
-              <a:latin typeface="Calibri"/>
+            <a:pPr algn="ctr">
+              <a:buNone/>
+            </a:pPr>
+            <a:endParaRPr b="0" lang="en-US" sz="4400" spc="-1" strike="noStrike">
+              <a:latin typeface="Arial"/>
             </a:endParaRPr>
           </a:p>
         </p:txBody>
@@ -116,11 +116,8 @@
             <a:normAutofit/>
           </a:bodyPr>
           <a:p>
-            <a:endParaRPr b="0" lang="en-US" sz="1800" spc="-1" strike="noStrike">
-              <a:solidFill>
-                <a:srgbClr val="000000"/>
-              </a:solidFill>
-              <a:latin typeface="Calibri"/>
+            <a:endParaRPr b="0" lang="en-US" sz="3200" spc="-1" strike="noStrike">
+              <a:latin typeface="Arial"/>
             </a:endParaRPr>
           </a:p>
         </p:txBody>
@@ -153,11 +150,8 @@
             <a:normAutofit/>
           </a:bodyPr>
           <a:p>
-            <a:endParaRPr b="0" lang="en-US" sz="1800" spc="-1" strike="noStrike">
-              <a:solidFill>
-                <a:srgbClr val="000000"/>
-              </a:solidFill>
-              <a:latin typeface="Calibri"/>
+            <a:endParaRPr b="0" lang="en-US" sz="3200" spc="-1" strike="noStrike">
+              <a:latin typeface="Arial"/>
             </a:endParaRPr>
           </a:p>
         </p:txBody>
@@ -212,11 +206,11 @@
             <a:noAutofit/>
           </a:bodyPr>
           <a:p>
-            <a:endParaRPr b="0" lang="en-US" sz="1800" spc="-1" strike="noStrike">
-              <a:solidFill>
-                <a:srgbClr val="000000"/>
-              </a:solidFill>
-              <a:latin typeface="Calibri"/>
+            <a:pPr algn="ctr">
+              <a:buNone/>
+            </a:pPr>
+            <a:endParaRPr b="0" lang="en-US" sz="4400" spc="-1" strike="noStrike">
+              <a:latin typeface="Arial"/>
             </a:endParaRPr>
           </a:p>
         </p:txBody>
@@ -249,11 +243,8 @@
             <a:normAutofit/>
           </a:bodyPr>
           <a:p>
-            <a:endParaRPr b="0" lang="en-US" sz="1800" spc="-1" strike="noStrike">
-              <a:solidFill>
-                <a:srgbClr val="000000"/>
-              </a:solidFill>
-              <a:latin typeface="Calibri"/>
+            <a:endParaRPr b="0" lang="en-US" sz="3200" spc="-1" strike="noStrike">
+              <a:latin typeface="Arial"/>
             </a:endParaRPr>
           </a:p>
         </p:txBody>
@@ -286,11 +277,8 @@
             <a:normAutofit/>
           </a:bodyPr>
           <a:p>
-            <a:endParaRPr b="0" lang="en-US" sz="1800" spc="-1" strike="noStrike">
-              <a:solidFill>
-                <a:srgbClr val="000000"/>
-              </a:solidFill>
-              <a:latin typeface="Calibri"/>
+            <a:endParaRPr b="0" lang="en-US" sz="3200" spc="-1" strike="noStrike">
+              <a:latin typeface="Arial"/>
             </a:endParaRPr>
           </a:p>
         </p:txBody>
@@ -323,11 +311,8 @@
             <a:normAutofit/>
           </a:bodyPr>
           <a:p>
-            <a:endParaRPr b="0" lang="en-US" sz="1800" spc="-1" strike="noStrike">
-              <a:solidFill>
-                <a:srgbClr val="000000"/>
-              </a:solidFill>
-              <a:latin typeface="Calibri"/>
+            <a:endParaRPr b="0" lang="en-US" sz="3200" spc="-1" strike="noStrike">
+              <a:latin typeface="Arial"/>
             </a:endParaRPr>
           </a:p>
         </p:txBody>
@@ -360,11 +345,8 @@
             <a:normAutofit/>
           </a:bodyPr>
           <a:p>
-            <a:endParaRPr b="0" lang="en-US" sz="1800" spc="-1" strike="noStrike">
-              <a:solidFill>
-                <a:srgbClr val="000000"/>
-              </a:solidFill>
-              <a:latin typeface="Calibri"/>
+            <a:endParaRPr b="0" lang="en-US" sz="3200" spc="-1" strike="noStrike">
+              <a:latin typeface="Arial"/>
             </a:endParaRPr>
           </a:p>
         </p:txBody>
@@ -419,11 +401,11 @@
             <a:noAutofit/>
           </a:bodyPr>
           <a:p>
-            <a:endParaRPr b="0" lang="en-US" sz="1800" spc="-1" strike="noStrike">
-              <a:solidFill>
-                <a:srgbClr val="000000"/>
-              </a:solidFill>
-              <a:latin typeface="Calibri"/>
+            <a:pPr algn="ctr">
+              <a:buNone/>
+            </a:pPr>
+            <a:endParaRPr b="0" lang="en-US" sz="4400" spc="-1" strike="noStrike">
+              <a:latin typeface="Arial"/>
             </a:endParaRPr>
           </a:p>
         </p:txBody>
@@ -456,11 +438,8 @@
             <a:normAutofit/>
           </a:bodyPr>
           <a:p>
-            <a:endParaRPr b="0" lang="en-US" sz="1800" spc="-1" strike="noStrike">
-              <a:solidFill>
-                <a:srgbClr val="000000"/>
-              </a:solidFill>
-              <a:latin typeface="Calibri"/>
+            <a:endParaRPr b="0" lang="en-US" sz="3200" spc="-1" strike="noStrike">
+              <a:latin typeface="Arial"/>
             </a:endParaRPr>
           </a:p>
         </p:txBody>
@@ -493,11 +472,8 @@
             <a:normAutofit/>
           </a:bodyPr>
           <a:p>
-            <a:endParaRPr b="0" lang="en-US" sz="1800" spc="-1" strike="noStrike">
-              <a:solidFill>
-                <a:srgbClr val="000000"/>
-              </a:solidFill>
-              <a:latin typeface="Calibri"/>
+            <a:endParaRPr b="0" lang="en-US" sz="3200" spc="-1" strike="noStrike">
+              <a:latin typeface="Arial"/>
             </a:endParaRPr>
           </a:p>
         </p:txBody>
@@ -530,11 +506,8 @@
             <a:normAutofit/>
           </a:bodyPr>
           <a:p>
-            <a:endParaRPr b="0" lang="en-US" sz="1800" spc="-1" strike="noStrike">
-              <a:solidFill>
-                <a:srgbClr val="000000"/>
-              </a:solidFill>
-              <a:latin typeface="Calibri"/>
+            <a:endParaRPr b="0" lang="en-US" sz="3200" spc="-1" strike="noStrike">
+              <a:latin typeface="Arial"/>
             </a:endParaRPr>
           </a:p>
         </p:txBody>
@@ -567,11 +540,8 @@
             <a:normAutofit/>
           </a:bodyPr>
           <a:p>
-            <a:endParaRPr b="0" lang="en-US" sz="1800" spc="-1" strike="noStrike">
-              <a:solidFill>
-                <a:srgbClr val="000000"/>
-              </a:solidFill>
-              <a:latin typeface="Calibri"/>
+            <a:endParaRPr b="0" lang="en-US" sz="3200" spc="-1" strike="noStrike">
+              <a:latin typeface="Arial"/>
             </a:endParaRPr>
           </a:p>
         </p:txBody>
@@ -604,11 +574,8 @@
             <a:normAutofit/>
           </a:bodyPr>
           <a:p>
-            <a:endParaRPr b="0" lang="en-US" sz="1800" spc="-1" strike="noStrike">
-              <a:solidFill>
-                <a:srgbClr val="000000"/>
-              </a:solidFill>
-              <a:latin typeface="Calibri"/>
+            <a:endParaRPr b="0" lang="en-US" sz="3200" spc="-1" strike="noStrike">
+              <a:latin typeface="Arial"/>
             </a:endParaRPr>
           </a:p>
         </p:txBody>
@@ -641,11 +608,8 @@
             <a:normAutofit/>
           </a:bodyPr>
           <a:p>
-            <a:endParaRPr b="0" lang="en-US" sz="1800" spc="-1" strike="noStrike">
-              <a:solidFill>
-                <a:srgbClr val="000000"/>
-              </a:solidFill>
-              <a:latin typeface="Calibri"/>
+            <a:endParaRPr b="0" lang="en-US" sz="3200" spc="-1" strike="noStrike">
+              <a:latin typeface="Arial"/>
             </a:endParaRPr>
           </a:p>
         </p:txBody>
@@ -700,11 +664,11 @@
             <a:noAutofit/>
           </a:bodyPr>
           <a:p>
-            <a:endParaRPr b="0" lang="en-US" sz="1800" spc="-1" strike="noStrike">
-              <a:solidFill>
-                <a:srgbClr val="000000"/>
-              </a:solidFill>
-              <a:latin typeface="Calibri"/>
+            <a:pPr algn="ctr">
+              <a:buNone/>
+            </a:pPr>
+            <a:endParaRPr b="0" lang="en-US" sz="4400" spc="-1" strike="noStrike">
+              <a:latin typeface="Arial"/>
             </a:endParaRPr>
           </a:p>
         </p:txBody>
@@ -796,11 +760,11 @@
             <a:noAutofit/>
           </a:bodyPr>
           <a:p>
-            <a:endParaRPr b="0" lang="en-US" sz="1800" spc="-1" strike="noStrike">
-              <a:solidFill>
-                <a:srgbClr val="000000"/>
-              </a:solidFill>
-              <a:latin typeface="Calibri"/>
+            <a:pPr algn="ctr">
+              <a:buNone/>
+            </a:pPr>
+            <a:endParaRPr b="0" lang="en-US" sz="4400" spc="-1" strike="noStrike">
+              <a:latin typeface="Arial"/>
             </a:endParaRPr>
           </a:p>
         </p:txBody>
@@ -833,11 +797,8 @@
             <a:normAutofit/>
           </a:bodyPr>
           <a:p>
-            <a:endParaRPr b="0" lang="en-US" sz="1800" spc="-1" strike="noStrike">
-              <a:solidFill>
-                <a:srgbClr val="000000"/>
-              </a:solidFill>
-              <a:latin typeface="Calibri"/>
+            <a:endParaRPr b="0" lang="en-US" sz="3200" spc="-1" strike="noStrike">
+              <a:latin typeface="Arial"/>
             </a:endParaRPr>
           </a:p>
         </p:txBody>
@@ -892,11 +853,11 @@
             <a:noAutofit/>
           </a:bodyPr>
           <a:p>
-            <a:endParaRPr b="0" lang="en-US" sz="1800" spc="-1" strike="noStrike">
-              <a:solidFill>
-                <a:srgbClr val="000000"/>
-              </a:solidFill>
-              <a:latin typeface="Calibri"/>
+            <a:pPr algn="ctr">
+              <a:buNone/>
+            </a:pPr>
+            <a:endParaRPr b="0" lang="en-US" sz="4400" spc="-1" strike="noStrike">
+              <a:latin typeface="Arial"/>
             </a:endParaRPr>
           </a:p>
         </p:txBody>
@@ -929,11 +890,8 @@
             <a:normAutofit/>
           </a:bodyPr>
           <a:p>
-            <a:endParaRPr b="0" lang="en-US" sz="1800" spc="-1" strike="noStrike">
-              <a:solidFill>
-                <a:srgbClr val="000000"/>
-              </a:solidFill>
-              <a:latin typeface="Calibri"/>
+            <a:endParaRPr b="0" lang="en-US" sz="3200" spc="-1" strike="noStrike">
+              <a:latin typeface="Arial"/>
             </a:endParaRPr>
           </a:p>
         </p:txBody>
@@ -966,11 +924,8 @@
             <a:normAutofit/>
           </a:bodyPr>
           <a:p>
-            <a:endParaRPr b="0" lang="en-US" sz="1800" spc="-1" strike="noStrike">
-              <a:solidFill>
-                <a:srgbClr val="000000"/>
-              </a:solidFill>
-              <a:latin typeface="Calibri"/>
+            <a:endParaRPr b="0" lang="en-US" sz="3200" spc="-1" strike="noStrike">
+              <a:latin typeface="Arial"/>
             </a:endParaRPr>
           </a:p>
         </p:txBody>
@@ -1025,11 +980,11 @@
             <a:noAutofit/>
           </a:bodyPr>
           <a:p>
-            <a:endParaRPr b="0" lang="en-US" sz="1800" spc="-1" strike="noStrike">
-              <a:solidFill>
-                <a:srgbClr val="000000"/>
-              </a:solidFill>
-              <a:latin typeface="Calibri"/>
+            <a:pPr algn="ctr">
+              <a:buNone/>
+            </a:pPr>
+            <a:endParaRPr b="0" lang="en-US" sz="4400" spc="-1" strike="noStrike">
+              <a:latin typeface="Arial"/>
             </a:endParaRPr>
           </a:p>
         </p:txBody>
@@ -1143,11 +1098,11 @@
             <a:noAutofit/>
           </a:bodyPr>
           <a:p>
-            <a:endParaRPr b="0" lang="en-US" sz="1800" spc="-1" strike="noStrike">
-              <a:solidFill>
-                <a:srgbClr val="000000"/>
-              </a:solidFill>
-              <a:latin typeface="Calibri"/>
+            <a:pPr algn="ctr">
+              <a:buNone/>
+            </a:pPr>
+            <a:endParaRPr b="0" lang="en-US" sz="4400" spc="-1" strike="noStrike">
+              <a:latin typeface="Arial"/>
             </a:endParaRPr>
           </a:p>
         </p:txBody>
@@ -1180,11 +1135,8 @@
             <a:normAutofit/>
           </a:bodyPr>
           <a:p>
-            <a:endParaRPr b="0" lang="en-US" sz="1800" spc="-1" strike="noStrike">
-              <a:solidFill>
-                <a:srgbClr val="000000"/>
-              </a:solidFill>
-              <a:latin typeface="Calibri"/>
+            <a:endParaRPr b="0" lang="en-US" sz="3200" spc="-1" strike="noStrike">
+              <a:latin typeface="Arial"/>
             </a:endParaRPr>
           </a:p>
         </p:txBody>
@@ -1217,11 +1169,8 @@
             <a:normAutofit/>
           </a:bodyPr>
           <a:p>
-            <a:endParaRPr b="0" lang="en-US" sz="1800" spc="-1" strike="noStrike">
-              <a:solidFill>
-                <a:srgbClr val="000000"/>
-              </a:solidFill>
-              <a:latin typeface="Calibri"/>
+            <a:endParaRPr b="0" lang="en-US" sz="3200" spc="-1" strike="noStrike">
+              <a:latin typeface="Arial"/>
             </a:endParaRPr>
           </a:p>
         </p:txBody>
@@ -1254,11 +1203,8 @@
             <a:normAutofit/>
           </a:bodyPr>
           <a:p>
-            <a:endParaRPr b="0" lang="en-US" sz="1800" spc="-1" strike="noStrike">
-              <a:solidFill>
-                <a:srgbClr val="000000"/>
-              </a:solidFill>
-              <a:latin typeface="Calibri"/>
+            <a:endParaRPr b="0" lang="en-US" sz="3200" spc="-1" strike="noStrike">
+              <a:latin typeface="Arial"/>
             </a:endParaRPr>
           </a:p>
         </p:txBody>
@@ -1313,11 +1259,11 @@
             <a:noAutofit/>
           </a:bodyPr>
           <a:p>
-            <a:endParaRPr b="0" lang="en-US" sz="1800" spc="-1" strike="noStrike">
-              <a:solidFill>
-                <a:srgbClr val="000000"/>
-              </a:solidFill>
-              <a:latin typeface="Calibri"/>
+            <a:pPr algn="ctr">
+              <a:buNone/>
+            </a:pPr>
+            <a:endParaRPr b="0" lang="en-US" sz="4400" spc="-1" strike="noStrike">
+              <a:latin typeface="Arial"/>
             </a:endParaRPr>
           </a:p>
         </p:txBody>
@@ -1350,11 +1296,8 @@
             <a:normAutofit/>
           </a:bodyPr>
           <a:p>
-            <a:endParaRPr b="0" lang="en-US" sz="1800" spc="-1" strike="noStrike">
-              <a:solidFill>
-                <a:srgbClr val="000000"/>
-              </a:solidFill>
-              <a:latin typeface="Calibri"/>
+            <a:endParaRPr b="0" lang="en-US" sz="3200" spc="-1" strike="noStrike">
+              <a:latin typeface="Arial"/>
             </a:endParaRPr>
           </a:p>
         </p:txBody>
@@ -1387,11 +1330,8 @@
             <a:normAutofit/>
           </a:bodyPr>
           <a:p>
-            <a:endParaRPr b="0" lang="en-US" sz="1800" spc="-1" strike="noStrike">
-              <a:solidFill>
-                <a:srgbClr val="000000"/>
-              </a:solidFill>
-              <a:latin typeface="Calibri"/>
+            <a:endParaRPr b="0" lang="en-US" sz="3200" spc="-1" strike="noStrike">
+              <a:latin typeface="Arial"/>
             </a:endParaRPr>
           </a:p>
         </p:txBody>
@@ -1424,11 +1364,8 @@
             <a:normAutofit/>
           </a:bodyPr>
           <a:p>
-            <a:endParaRPr b="0" lang="en-US" sz="1800" spc="-1" strike="noStrike">
-              <a:solidFill>
-                <a:srgbClr val="000000"/>
-              </a:solidFill>
-              <a:latin typeface="Calibri"/>
+            <a:endParaRPr b="0" lang="en-US" sz="3200" spc="-1" strike="noStrike">
+              <a:latin typeface="Arial"/>
             </a:endParaRPr>
           </a:p>
         </p:txBody>
@@ -1483,11 +1420,11 @@
             <a:noAutofit/>
           </a:bodyPr>
           <a:p>
-            <a:endParaRPr b="0" lang="en-US" sz="1800" spc="-1" strike="noStrike">
-              <a:solidFill>
-                <a:srgbClr val="000000"/>
-              </a:solidFill>
-              <a:latin typeface="Calibri"/>
+            <a:pPr algn="ctr">
+              <a:buNone/>
+            </a:pPr>
+            <a:endParaRPr b="0" lang="en-US" sz="4400" spc="-1" strike="noStrike">
+              <a:latin typeface="Arial"/>
             </a:endParaRPr>
           </a:p>
         </p:txBody>
@@ -1520,11 +1457,8 @@
             <a:normAutofit/>
           </a:bodyPr>
           <a:p>
-            <a:endParaRPr b="0" lang="en-US" sz="1800" spc="-1" strike="noStrike">
-              <a:solidFill>
-                <a:srgbClr val="000000"/>
-              </a:solidFill>
-              <a:latin typeface="Calibri"/>
+            <a:endParaRPr b="0" lang="en-US" sz="3200" spc="-1" strike="noStrike">
+              <a:latin typeface="Arial"/>
             </a:endParaRPr>
           </a:p>
         </p:txBody>
@@ -1557,11 +1491,8 @@
             <a:normAutofit/>
           </a:bodyPr>
           <a:p>
-            <a:endParaRPr b="0" lang="en-US" sz="1800" spc="-1" strike="noStrike">
-              <a:solidFill>
-                <a:srgbClr val="000000"/>
-              </a:solidFill>
-              <a:latin typeface="Calibri"/>
+            <a:endParaRPr b="0" lang="en-US" sz="3200" spc="-1" strike="noStrike">
+              <a:latin typeface="Arial"/>
             </a:endParaRPr>
           </a:p>
         </p:txBody>
@@ -1594,11 +1525,8 @@
             <a:normAutofit/>
           </a:bodyPr>
           <a:p>
-            <a:endParaRPr b="0" lang="en-US" sz="1800" spc="-1" strike="noStrike">
-              <a:solidFill>
-                <a:srgbClr val="000000"/>
-              </a:solidFill>
-              <a:latin typeface="Calibri"/>
+            <a:endParaRPr b="0" lang="en-US" sz="3200" spc="-1" strike="noStrike">
+              <a:latin typeface="Arial"/>
             </a:endParaRPr>
           </a:p>
         </p:txBody>
@@ -1678,7 +1606,7 @@
         <p:spPr>
           <a:xfrm>
             <a:off x="2505600" y="2002680"/>
-            <a:ext cx="9292320" cy="2151360"/>
+            <a:ext cx="9291960" cy="2151000"/>
           </a:xfrm>
           <a:prstGeom prst="roundRect">
             <a:avLst>
@@ -1711,7 +1639,7 @@
         <p:spPr>
           <a:xfrm>
             <a:off x="8071920" y="675720"/>
-            <a:ext cx="6321240" cy="1005480"/>
+            <a:ext cx="6320880" cy="1005120"/>
           </a:xfrm>
           <a:prstGeom prst="roundRect">
             <a:avLst>
@@ -1744,7 +1672,7 @@
         <p:spPr>
           <a:xfrm>
             <a:off x="180720" y="669240"/>
-            <a:ext cx="1986480" cy="2683080"/>
+            <a:ext cx="1986120" cy="2682720"/>
           </a:xfrm>
           <a:prstGeom prst="roundRect">
             <a:avLst>
@@ -1777,7 +1705,7 @@
         <p:spPr>
           <a:xfrm>
             <a:off x="12304800" y="2011680"/>
-            <a:ext cx="2086200" cy="3491280"/>
+            <a:ext cx="2085840" cy="3490920"/>
           </a:xfrm>
           <a:prstGeom prst="roundRect">
             <a:avLst>
@@ -1810,7 +1738,7 @@
         <p:spPr>
           <a:xfrm>
             <a:off x="3604320" y="4489920"/>
-            <a:ext cx="4515120" cy="1005480"/>
+            <a:ext cx="4514760" cy="1005120"/>
           </a:xfrm>
           <a:prstGeom prst="roundRect">
             <a:avLst>
@@ -1843,7 +1771,7 @@
         <p:spPr>
           <a:xfrm>
             <a:off x="8556840" y="4482000"/>
-            <a:ext cx="3431520" cy="1005480"/>
+            <a:ext cx="3431160" cy="1005120"/>
           </a:xfrm>
           <a:prstGeom prst="roundRect">
             <a:avLst>
@@ -1876,7 +1804,7 @@
         <p:spPr>
           <a:xfrm>
             <a:off x="2709360" y="2095560"/>
-            <a:ext cx="2347560" cy="1089360"/>
+            <a:ext cx="2347200" cy="1089000"/>
           </a:xfrm>
           <a:prstGeom prst="roundRect">
             <a:avLst>
@@ -1916,6 +1844,7 @@
                   <a:srgbClr val="16213a"/>
                 </a:solidFill>
                 <a:latin typeface="Times New Roman"/>
+                <a:ea typeface="DejaVu Sans"/>
               </a:rPr>
               <a:t>(1) Frozen LLM parse</a:t>
             </a:r>
@@ -1936,6 +1865,7 @@
                   <a:srgbClr val="16213a"/>
                 </a:solidFill>
                 <a:latin typeface="Times New Roman"/>
+                <a:ea typeface="DejaVu Sans"/>
               </a:rPr>
               <a:t>→ </a:t>
             </a:r>
@@ -1945,6 +1875,7 @@
                   <a:srgbClr val="16213a"/>
                 </a:solidFill>
                 <a:latin typeface="Times New Roman"/>
+                <a:ea typeface="DejaVu Sans"/>
               </a:rPr>
               <a:t>nested STL tree</a:t>
             </a:r>
@@ -1963,7 +1894,7 @@
         <p:spPr>
           <a:xfrm>
             <a:off x="2664000" y="3285720"/>
-            <a:ext cx="2437920" cy="804240"/>
+            <a:ext cx="2437560" cy="803880"/>
           </a:xfrm>
           <a:prstGeom prst="roundRect">
             <a:avLst>
@@ -1996,7 +1927,7 @@
         <p:spPr>
           <a:xfrm>
             <a:off x="5418720" y="2095560"/>
-            <a:ext cx="2076840" cy="1089360"/>
+            <a:ext cx="2076480" cy="1089000"/>
           </a:xfrm>
           <a:prstGeom prst="roundRect">
             <a:avLst>
@@ -2036,6 +1967,7 @@
                   <a:srgbClr val="16213a"/>
                 </a:solidFill>
                 <a:latin typeface="Times New Roman"/>
+                <a:ea typeface="DejaVu Sans"/>
               </a:rPr>
               <a:t>(2) Render robustness</a:t>
             </a:r>
@@ -2056,6 +1988,7 @@
                   <a:srgbClr val="16213a"/>
                 </a:solidFill>
                 <a:latin typeface="Times New Roman"/>
+                <a:ea typeface="DejaVu Sans"/>
               </a:rPr>
               <a:t>STL φ, diff. ρ</a:t>
             </a:r>
@@ -2074,7 +2007,7 @@
         <p:spPr>
           <a:xfrm>
             <a:off x="5373360" y="3285720"/>
-            <a:ext cx="2167200" cy="586440"/>
+            <a:ext cx="2166840" cy="586080"/>
           </a:xfrm>
           <a:prstGeom prst="roundRect">
             <a:avLst>
@@ -2107,7 +2040,7 @@
         <p:spPr>
           <a:xfrm>
             <a:off x="7857000" y="2095560"/>
-            <a:ext cx="3792600" cy="1089360"/>
+            <a:ext cx="3792240" cy="1089000"/>
           </a:xfrm>
           <a:prstGeom prst="roundRect">
             <a:avLst>
@@ -2140,7 +2073,7 @@
         <p:spPr>
           <a:xfrm>
             <a:off x="8037720" y="2522880"/>
-            <a:ext cx="857520" cy="443880"/>
+            <a:ext cx="857160" cy="443520"/>
           </a:xfrm>
           <a:prstGeom prst="roundRect">
             <a:avLst>
@@ -2180,6 +2113,7 @@
                   <a:srgbClr val="16213a"/>
                 </a:solidFill>
                 <a:latin typeface="Times New Roman"/>
+                <a:ea typeface="DejaVu Sans"/>
               </a:rPr>
               <a:t>GNN</a:t>
             </a:r>
@@ -2200,6 +2134,7 @@
                   <a:srgbClr val="16213a"/>
                 </a:solidFill>
                 <a:latin typeface="Times New Roman"/>
+                <a:ea typeface="DejaVu Sans"/>
               </a:rPr>
               <a:t>encoder</a:t>
             </a:r>
@@ -2218,7 +2153,7 @@
         <p:spPr>
           <a:xfrm>
             <a:off x="8579520" y="3285720"/>
-            <a:ext cx="2889720" cy="586440"/>
+            <a:ext cx="2889360" cy="586080"/>
           </a:xfrm>
           <a:prstGeom prst="roundRect">
             <a:avLst>
@@ -2251,7 +2186,7 @@
         <p:spPr>
           <a:xfrm>
             <a:off x="9211680" y="2581560"/>
-            <a:ext cx="360720" cy="334800"/>
+            <a:ext cx="360360" cy="334440"/>
           </a:xfrm>
           <a:prstGeom prst="ellipse">
             <a:avLst/>
@@ -2289,6 +2224,7 @@
                   <a:srgbClr val="16213a"/>
                 </a:solidFill>
                 <a:latin typeface="Times New Roman"/>
+                <a:ea typeface="DejaVu Sans"/>
               </a:rPr>
               <a:t>x</a:t>
             </a:r>
@@ -2298,6 +2234,7 @@
                   <a:srgbClr val="16213a"/>
                 </a:solidFill>
                 <a:latin typeface="Times New Roman"/>
+                <a:ea typeface="DejaVu Sans"/>
               </a:rPr>
               <a:t>T</a:t>
             </a:r>
@@ -2316,7 +2253,7 @@
         <p:spPr>
           <a:xfrm>
             <a:off x="9753480" y="2581560"/>
-            <a:ext cx="360720" cy="334800"/>
+            <a:ext cx="360360" cy="334440"/>
           </a:xfrm>
           <a:prstGeom prst="ellipse">
             <a:avLst/>
@@ -2354,6 +2291,7 @@
                   <a:srgbClr val="16213a"/>
                 </a:solidFill>
                 <a:latin typeface="Times New Roman"/>
+                <a:ea typeface="DejaVu Sans"/>
               </a:rPr>
               <a:t>x</a:t>
             </a:r>
@@ -2363,6 +2301,7 @@
                   <a:srgbClr val="16213a"/>
                 </a:solidFill>
                 <a:latin typeface="Times New Roman"/>
+                <a:ea typeface="DejaVu Sans"/>
               </a:rPr>
               <a:t>t</a:t>
             </a:r>
@@ -2381,7 +2320,7 @@
         <p:spPr>
           <a:xfrm>
             <a:off x="10295640" y="2581560"/>
-            <a:ext cx="360720" cy="334800"/>
+            <a:ext cx="360360" cy="334440"/>
           </a:xfrm>
           <a:prstGeom prst="ellipse">
             <a:avLst/>
@@ -2419,6 +2358,7 @@
                   <a:srgbClr val="16213a"/>
                 </a:solidFill>
                 <a:latin typeface="Times New Roman"/>
+                <a:ea typeface="DejaVu Sans"/>
               </a:rPr>
               <a:t>⋯</a:t>
             </a:r>
@@ -2437,7 +2377,7 @@
         <p:spPr>
           <a:xfrm>
             <a:off x="10837440" y="2581560"/>
-            <a:ext cx="360720" cy="334800"/>
+            <a:ext cx="360360" cy="334440"/>
           </a:xfrm>
           <a:prstGeom prst="ellipse">
             <a:avLst/>
@@ -2475,6 +2415,7 @@
                   <a:srgbClr val="16213a"/>
                 </a:solidFill>
                 <a:latin typeface="Times New Roman"/>
+                <a:ea typeface="DejaVu Sans"/>
               </a:rPr>
               <a:t>x</a:t>
             </a:r>
@@ -2484,6 +2425,7 @@
                   <a:srgbClr val="16213a"/>
                 </a:solidFill>
                 <a:latin typeface="Times New Roman"/>
+                <a:ea typeface="DejaVu Sans"/>
               </a:rPr>
               <a:t>0</a:t>
             </a:r>
@@ -2502,7 +2444,7 @@
         <p:spPr>
           <a:xfrm>
             <a:off x="11212200" y="4746600"/>
-            <a:ext cx="586800" cy="544320"/>
+            <a:ext cx="586440" cy="543960"/>
           </a:xfrm>
           <a:prstGeom prst="roundRect">
             <a:avLst>
@@ -2542,6 +2484,7 @@
                   <a:srgbClr val="16213a"/>
                 </a:solidFill>
                 <a:latin typeface="Times New Roman"/>
+                <a:ea typeface="DejaVu Sans"/>
               </a:rPr>
               <a:t>A*</a:t>
             </a:r>
@@ -2908,7 +2851,7 @@
         <p:spPr>
           <a:xfrm flipV="1">
             <a:off x="13348080" y="1695240"/>
-            <a:ext cx="0" cy="316440"/>
+            <a:ext cx="360" cy="316440"/>
           </a:xfrm>
           <a:prstGeom prst="line">
             <a:avLst/>
@@ -2966,7 +2909,7 @@
         <p:spPr>
           <a:xfrm>
             <a:off x="180720" y="123480"/>
-            <a:ext cx="14385960" cy="339120"/>
+            <a:ext cx="14385600" cy="338760"/>
           </a:xfrm>
           <a:prstGeom prst="rect">
             <a:avLst/>
@@ -2999,6 +2942,7 @@
                   <a:srgbClr val="2c3e6b"/>
                 </a:solidFill>
                 <a:latin typeface="Times New Roman"/>
+                <a:ea typeface="DejaVu Sans"/>
               </a:rPr>
               <a:t>NL2TL-Tree: Natural Language to Robot Trajectory Pipeline</a:t>
             </a:r>
@@ -3017,7 +2961,7 @@
         <p:spPr>
           <a:xfrm>
             <a:off x="4602600" y="1702800"/>
-            <a:ext cx="5119560" cy="285120"/>
+            <a:ext cx="5119200" cy="284760"/>
           </a:xfrm>
           <a:prstGeom prst="rect">
             <a:avLst/>
@@ -3050,6 +2994,7 @@
                   <a:srgbClr val="2c3e6b"/>
                 </a:solidFill>
                 <a:latin typeface="Times New Roman"/>
+                <a:ea typeface="DejaVu Sans"/>
               </a:rPr>
               <a:t>Training-free pipeline  </a:t>
             </a:r>
@@ -3068,7 +3013,7 @@
         <p:spPr>
           <a:xfrm>
             <a:off x="219960" y="740520"/>
-            <a:ext cx="1929960" cy="463320"/>
+            <a:ext cx="1929600" cy="462960"/>
           </a:xfrm>
           <a:prstGeom prst="rect">
             <a:avLst/>
@@ -3101,6 +3046,7 @@
                   <a:srgbClr val="16213a"/>
                 </a:solidFill>
                 <a:latin typeface="Times New Roman"/>
+                <a:ea typeface="DejaVu Sans"/>
               </a:rPr>
               <a:t>Natural-language</a:t>
             </a:r>
@@ -3121,6 +3067,7 @@
                   <a:srgbClr val="16213a"/>
                 </a:solidFill>
                 <a:latin typeface="Times New Roman"/>
+                <a:ea typeface="DejaVu Sans"/>
               </a:rPr>
               <a:t>task  (phone)</a:t>
             </a:r>
@@ -3139,7 +3086,7 @@
         <p:spPr>
           <a:xfrm>
             <a:off x="334440" y="2896560"/>
-            <a:ext cx="1678680" cy="385560"/>
+            <a:ext cx="1678320" cy="385200"/>
           </a:xfrm>
           <a:prstGeom prst="rect">
             <a:avLst/>
@@ -3172,6 +3119,7 @@
                   <a:srgbClr val="33513a"/>
                 </a:solidFill>
                 <a:latin typeface="Times New Roman"/>
+                <a:ea typeface="DejaVu Sans"/>
               </a:rPr>
               <a:t>“</a:t>
             </a:r>
@@ -3181,6 +3129,7 @@
                   <a:srgbClr val="33513a"/>
                 </a:solidFill>
                 <a:latin typeface="Times New Roman"/>
+                <a:ea typeface="DejaVu Sans"/>
               </a:rPr>
               <a:t>visit A, then B;</a:t>
             </a:r>
@@ -3201,6 +3150,7 @@
                   <a:srgbClr val="33513a"/>
                 </a:solidFill>
                 <a:latin typeface="Times New Roman"/>
+                <a:ea typeface="DejaVu Sans"/>
               </a:rPr>
               <a:t>always keep safe”</a:t>
             </a:r>
@@ -3219,7 +3169,7 @@
         <p:spPr>
           <a:xfrm>
             <a:off x="7891560" y="2161080"/>
-            <a:ext cx="3723840" cy="254160"/>
+            <a:ext cx="3723480" cy="253800"/>
           </a:xfrm>
           <a:prstGeom prst="rect">
             <a:avLst/>
@@ -3252,6 +3202,7 @@
                   <a:srgbClr val="16213a"/>
                 </a:solidFill>
                 <a:latin typeface="Times New Roman"/>
+                <a:ea typeface="DejaVu Sans"/>
               </a:rPr>
               <a:t>(3) Flow-matching planner (TeLoGraF)</a:t>
             </a:r>
@@ -3270,7 +3221,7 @@
         <p:spPr>
           <a:xfrm>
             <a:off x="8740800" y="2919600"/>
-            <a:ext cx="2909160" cy="224640"/>
+            <a:ext cx="2908800" cy="224280"/>
           </a:xfrm>
           <a:prstGeom prst="rect">
             <a:avLst/>
@@ -3303,6 +3254,7 @@
                   <a:srgbClr val="16213a"/>
                 </a:solidFill>
                 <a:latin typeface="Times New Roman"/>
+                <a:ea typeface="DejaVu Sans"/>
               </a:rPr>
               <a:t>flow sampling + STLCG ∇ρ guidance</a:t>
             </a:r>
@@ -3321,7 +3273,7 @@
         <p:spPr>
           <a:xfrm>
             <a:off x="12879720" y="2295720"/>
-            <a:ext cx="882360" cy="269640"/>
+            <a:ext cx="882000" cy="269280"/>
           </a:xfrm>
           <a:prstGeom prst="rect">
             <a:avLst/>
@@ -3354,6 +3306,7 @@
                   <a:srgbClr val="7a4d1c"/>
                 </a:solidFill>
                 <a:latin typeface="Times New Roman"/>
+                <a:ea typeface="DejaVu Sans"/>
               </a:rPr>
               <a:t>Output</a:t>
             </a:r>
@@ -3372,7 +3325,7 @@
         <p:spPr>
           <a:xfrm>
             <a:off x="12146040" y="2646360"/>
-            <a:ext cx="2349000" cy="540720"/>
+            <a:ext cx="2348640" cy="540360"/>
           </a:xfrm>
           <a:prstGeom prst="rect">
             <a:avLst/>
@@ -3405,6 +3358,7 @@
                   <a:srgbClr val="16213a"/>
                 </a:solidFill>
                 <a:latin typeface="Times New Roman"/>
+                <a:ea typeface="DejaVu Sans"/>
               </a:rPr>
               <a:t>STL-satisfying</a:t>
             </a:r>
@@ -3425,6 +3379,7 @@
                   <a:srgbClr val="16213a"/>
                 </a:solidFill>
                 <a:latin typeface="Times New Roman"/>
+                <a:ea typeface="DejaVu Sans"/>
               </a:rPr>
               <a:t>trajectory τ</a:t>
             </a:r>
@@ -3445,6 +3400,7 @@
                   <a:srgbClr val="16213a"/>
                 </a:solidFill>
                 <a:latin typeface="Times New Roman"/>
+                <a:ea typeface="DejaVu Sans"/>
               </a:rPr>
               <a:t>ρ(G¬unsafe)&gt;0 (certified)</a:t>
             </a:r>
@@ -3463,7 +3419,7 @@
         <p:spPr>
           <a:xfrm>
             <a:off x="3780360" y="4132440"/>
-            <a:ext cx="2558520" cy="269640"/>
+            <a:ext cx="2558160" cy="269280"/>
           </a:xfrm>
           <a:prstGeom prst="rect">
             <a:avLst/>
@@ -3496,6 +3452,7 @@
                   <a:srgbClr val="2a8a7a"/>
                 </a:solidFill>
                 <a:latin typeface="Times New Roman"/>
+                <a:ea typeface="DejaVu Sans"/>
               </a:rPr>
               <a:t>Checks + user feedback</a:t>
             </a:r>
@@ -3514,7 +3471,7 @@
         <p:spPr>
           <a:xfrm>
             <a:off x="3660480" y="4593240"/>
-            <a:ext cx="4402800" cy="246240"/>
+            <a:ext cx="4402440" cy="245880"/>
           </a:xfrm>
           <a:prstGeom prst="rect">
             <a:avLst/>
@@ -3547,6 +3504,7 @@
                   <a:srgbClr val="115555"/>
                 </a:solidFill>
                 <a:latin typeface="Times New Roman"/>
+                <a:ea typeface="DejaVu Sans"/>
               </a:rPr>
               <a:t>Pre-flight feasibility gauge  (A* + dynamics)</a:t>
             </a:r>
@@ -3565,7 +3523,7 @@
         <p:spPr>
           <a:xfrm>
             <a:off x="3321000" y="4998960"/>
-            <a:ext cx="5081760" cy="373320"/>
+            <a:ext cx="5081400" cy="372960"/>
           </a:xfrm>
           <a:prstGeom prst="rect">
             <a:avLst/>
@@ -3598,6 +3556,7 @@
                   <a:srgbClr val="16213a"/>
                 </a:solidFill>
                 <a:latin typeface="Times New Roman"/>
+                <a:ea typeface="DejaVu Sans"/>
               </a:rPr>
               <a:t>A* path × clutter + predicted planning latency  vs. deadline</a:t>
             </a:r>
@@ -3618,6 +3577,7 @@
                   <a:srgbClr val="16213a"/>
                 </a:solidFill>
                 <a:latin typeface="Times New Roman"/>
+                <a:ea typeface="DejaVu Sans"/>
               </a:rPr>
               <a:t>⇒ </a:t>
             </a:r>
@@ -3627,6 +3587,7 @@
                   <a:srgbClr val="16213a"/>
                 </a:solidFill>
                 <a:latin typeface="Times New Roman"/>
+                <a:ea typeface="DejaVu Sans"/>
               </a:rPr>
               <a:t>completability:  likely / tight / unlikely</a:t>
             </a:r>
@@ -3645,7 +3606,7 @@
         <p:spPr>
           <a:xfrm>
             <a:off x="9223920" y="4584960"/>
-            <a:ext cx="2097720" cy="246240"/>
+            <a:ext cx="2097360" cy="245880"/>
           </a:xfrm>
           <a:prstGeom prst="rect">
             <a:avLst/>
@@ -3678,6 +3639,7 @@
                   <a:srgbClr val="115555"/>
                 </a:solidFill>
                 <a:latin typeface="Times New Roman"/>
+                <a:ea typeface="DejaVu Sans"/>
               </a:rPr>
               <a:t>Best-of-N self-check</a:t>
             </a:r>
@@ -3696,7 +3658,7 @@
         <p:spPr>
           <a:xfrm>
             <a:off x="9130320" y="4991040"/>
-            <a:ext cx="2104560" cy="373320"/>
+            <a:ext cx="2104200" cy="372960"/>
           </a:xfrm>
           <a:prstGeom prst="rect">
             <a:avLst/>
@@ -3729,6 +3691,7 @@
                   <a:srgbClr val="16213a"/>
                 </a:solidFill>
                 <a:latin typeface="Times New Roman"/>
+                <a:ea typeface="DejaVu Sans"/>
               </a:rPr>
               <a:t>reach-shortfall &gt; τ ?</a:t>
             </a:r>
@@ -3749,6 +3712,7 @@
                   <a:srgbClr val="16213a"/>
                 </a:solidFill>
                 <a:latin typeface="Times New Roman"/>
+                <a:ea typeface="DejaVu Sans"/>
               </a:rPr>
               <a:t>→ </a:t>
             </a:r>
@@ -3758,6 +3722,7 @@
                   <a:srgbClr val="16213a"/>
                 </a:solidFill>
                 <a:latin typeface="Times New Roman"/>
+                <a:ea typeface="DejaVu Sans"/>
               </a:rPr>
               <a:t>visualize why + defer</a:t>
             </a:r>
@@ -3776,7 +3741,7 @@
         <p:spPr>
           <a:xfrm>
             <a:off x="11298240" y="4511880"/>
-            <a:ext cx="469800" cy="209160"/>
+            <a:ext cx="469440" cy="208800"/>
           </a:xfrm>
           <a:prstGeom prst="rect">
             <a:avLst/>
@@ -3809,6 +3774,7 @@
                   <a:srgbClr val="b03a2e"/>
                 </a:solidFill>
                 <a:latin typeface="Times New Roman"/>
+                <a:ea typeface="DejaVu Sans"/>
               </a:rPr>
               <a:t>OOD</a:t>
             </a:r>
@@ -3827,7 +3793,7 @@
         <p:spPr>
           <a:xfrm>
             <a:off x="791280" y="4064760"/>
-            <a:ext cx="1487520" cy="503640"/>
+            <a:ext cx="1487160" cy="503280"/>
           </a:xfrm>
           <a:prstGeom prst="rect">
             <a:avLst/>
@@ -3860,6 +3826,7 @@
                   <a:srgbClr val="7a4dbf"/>
                 </a:solidFill>
                 <a:latin typeface="Times New Roman"/>
+                <a:ea typeface="DejaVu Sans"/>
               </a:rPr>
               <a:t>feedback:</a:t>
             </a:r>
@@ -3880,6 +3847,7 @@
                   <a:srgbClr val="7a4dbf"/>
                 </a:solidFill>
                 <a:latin typeface="Times New Roman"/>
+                <a:ea typeface="DejaVu Sans"/>
               </a:rPr>
               <a:t>completability</a:t>
             </a:r>
@@ -3900,6 +3868,7 @@
                   <a:srgbClr val="7a4dbf"/>
                 </a:solidFill>
                 <a:latin typeface="Times New Roman"/>
+                <a:ea typeface="DejaVu Sans"/>
               </a:rPr>
               <a:t>+ why-infeasible</a:t>
             </a:r>
@@ -3918,7 +3887,7 @@
         <p:spPr>
           <a:xfrm>
             <a:off x="9187200" y="768240"/>
-            <a:ext cx="4012920" cy="254160"/>
+            <a:ext cx="4012560" cy="253800"/>
           </a:xfrm>
           <a:prstGeom prst="rect">
             <a:avLst/>
@@ -3951,6 +3920,7 @@
                   <a:srgbClr val="16213a"/>
                 </a:solidFill>
                 <a:latin typeface="Times New Roman"/>
+                <a:ea typeface="DejaVu Sans"/>
               </a:rPr>
               <a:t>Closed-loop execution  (sim TurtleBot3)</a:t>
             </a:r>
@@ -3969,7 +3939,7 @@
         <p:spPr>
           <a:xfrm>
             <a:off x="9086040" y="1740240"/>
-            <a:ext cx="781560" cy="215280"/>
+            <a:ext cx="781200" cy="214920"/>
           </a:xfrm>
           <a:prstGeom prst="rect">
             <a:avLst/>
@@ -4002,6 +3972,7 @@
                   <a:srgbClr val="5b5b78"/>
                 </a:solidFill>
                 <a:latin typeface="Times New Roman"/>
+                <a:ea typeface="DejaVu Sans"/>
               </a:rPr>
               <a:t>re-plan</a:t>
             </a:r>
@@ -4020,7 +3991,7 @@
         <p:spPr>
           <a:xfrm>
             <a:off x="2438280" y="676800"/>
-            <a:ext cx="5418360" cy="1005480"/>
+            <a:ext cx="5418000" cy="1005120"/>
           </a:xfrm>
           <a:prstGeom prst="roundRect">
             <a:avLst>
@@ -4053,7 +4024,7 @@
         <p:spPr>
           <a:xfrm>
             <a:off x="3149280" y="768240"/>
-            <a:ext cx="4012920" cy="254160"/>
+            <a:ext cx="4012560" cy="253800"/>
           </a:xfrm>
           <a:prstGeom prst="rect">
             <a:avLst/>
@@ -4086,6 +4057,7 @@
                   <a:srgbClr val="16213a"/>
                 </a:solidFill>
                 <a:latin typeface="Times New Roman"/>
+                <a:ea typeface="DejaVu Sans"/>
               </a:rPr>
               <a:t>Environment</a:t>
             </a:r>
@@ -4104,7 +4076,7 @@
         <p:spPr>
           <a:xfrm>
             <a:off x="2558520" y="1080000"/>
-            <a:ext cx="2489040" cy="539640"/>
+            <a:ext cx="2488680" cy="539280"/>
           </a:xfrm>
           <a:prstGeom prst="roundRect">
             <a:avLst>
@@ -4137,7 +4109,7 @@
         <p:spPr>
           <a:xfrm>
             <a:off x="5180760" y="1080000"/>
-            <a:ext cx="2556000" cy="539640"/>
+            <a:ext cx="2555640" cy="539280"/>
           </a:xfrm>
           <a:prstGeom prst="roundRect">
             <a:avLst>
@@ -4170,7 +4142,7 @@
         <p:spPr>
           <a:xfrm>
             <a:off x="12477240" y="1074240"/>
-            <a:ext cx="1819800" cy="499680"/>
+            <a:ext cx="1819440" cy="499320"/>
           </a:xfrm>
           <a:prstGeom prst="roundRect">
             <a:avLst>
@@ -4210,6 +4182,7 @@
                   <a:srgbClr val="16213a"/>
                 </a:solidFill>
                 <a:latin typeface="Times New Roman"/>
+                <a:ea typeface="DejaVu Sans"/>
               </a:rPr>
               <a:t>MPPI tracking</a:t>
             </a:r>
@@ -4230,17 +4203,9 @@
                   <a:srgbClr val="16213a"/>
                 </a:solidFill>
                 <a:latin typeface="Times New Roman"/>
-              </a:rPr>
-              <a:t>∼</a:t>
-            </a:r>
-            <a:r>
-              <a:rPr b="1" lang="en-US" sz="1050" spc="-1" strike="noStrike">
-                <a:solidFill>
-                  <a:srgbClr val="16213a"/>
-                </a:solidFill>
-                <a:latin typeface="Times New Roman"/>
-              </a:rPr>
-              <a:t>7 Hz</a:t>
+                <a:ea typeface="DejaVu Sans"/>
+              </a:rPr>
+              <a:t>(Dynamic obstacle handling) </a:t>
             </a:r>
             <a:endParaRPr b="0" lang="en-US" sz="1050" spc="-1" strike="noStrike">
               <a:latin typeface="Arial"/>
@@ -4257,7 +4222,7 @@
         <p:spPr>
           <a:xfrm>
             <a:off x="10321920" y="1074960"/>
-            <a:ext cx="1819800" cy="499680"/>
+            <a:ext cx="1819440" cy="499320"/>
           </a:xfrm>
           <a:prstGeom prst="roundRect">
             <a:avLst>
@@ -4297,6 +4262,7 @@
                   <a:srgbClr val="16213a"/>
                 </a:solidFill>
                 <a:latin typeface="Times New Roman"/>
+                <a:ea typeface="DejaVu Sans"/>
               </a:rPr>
               <a:t>Online sound ρ</a:t>
             </a:r>
@@ -4317,6 +4283,7 @@
                   <a:srgbClr val="16213a"/>
                 </a:solidFill>
                 <a:latin typeface="Times New Roman"/>
+                <a:ea typeface="DejaVu Sans"/>
               </a:rPr>
               <a:t>monitor</a:t>
             </a:r>
@@ -4335,7 +4302,7 @@
         <p:spPr>
           <a:xfrm>
             <a:off x="8166240" y="1074240"/>
-            <a:ext cx="1819800" cy="499680"/>
+            <a:ext cx="1819440" cy="499320"/>
           </a:xfrm>
           <a:prstGeom prst="roundRect">
             <a:avLst>
@@ -4375,6 +4342,7 @@
                   <a:srgbClr val="16213a"/>
                 </a:solidFill>
                 <a:latin typeface="Times New Roman"/>
+                <a:ea typeface="DejaVu Sans"/>
               </a:rPr>
               <a:t>Stop / re-plan</a:t>
             </a:r>
@@ -4395,6 +4363,7 @@
                   <a:srgbClr val="16213a"/>
                 </a:solidFill>
                 <a:latin typeface="Times New Roman"/>
+                <a:ea typeface="DejaVu Sans"/>
               </a:rPr>
               <a:t>(latency-aware)</a:t>
             </a:r>
@@ -4471,7 +4440,7 @@
         <p:spPr>
           <a:xfrm>
             <a:off x="2754000" y="3327840"/>
-            <a:ext cx="2257920" cy="179640"/>
+            <a:ext cx="2257560" cy="179280"/>
           </a:xfrm>
           <a:prstGeom prst="roundRect">
             <a:avLst>
@@ -4511,6 +4480,7 @@
                   <a:srgbClr val="16213a"/>
                 </a:solidFill>
                 <a:latin typeface="Times New Roman"/>
+                <a:ea typeface="DejaVu Sans"/>
               </a:rPr>
               <a:t>self-consistency vote</a:t>
             </a:r>
@@ -4529,7 +4499,7 @@
         <p:spPr>
           <a:xfrm>
             <a:off x="2754000" y="3597840"/>
-            <a:ext cx="2257920" cy="179640"/>
+            <a:ext cx="2257560" cy="179280"/>
           </a:xfrm>
           <a:prstGeom prst="roundRect">
             <a:avLst>
@@ -4569,6 +4539,7 @@
                   <a:srgbClr val="16213a"/>
                 </a:solidFill>
                 <a:latin typeface="Times New Roman"/>
+                <a:ea typeface="DejaVu Sans"/>
               </a:rPr>
               <a:t>round-trip scope refine</a:t>
             </a:r>
@@ -4587,7 +4558,7 @@
         <p:spPr>
           <a:xfrm>
             <a:off x="2754000" y="3867840"/>
-            <a:ext cx="2257920" cy="179640"/>
+            <a:ext cx="2257560" cy="179280"/>
           </a:xfrm>
           <a:prstGeom prst="roundRect">
             <a:avLst>
@@ -4627,6 +4598,7 @@
                   <a:srgbClr val="16213a"/>
                 </a:solidFill>
                 <a:latin typeface="Times New Roman"/>
+                <a:ea typeface="DejaVu Sans"/>
               </a:rPr>
               <a:t>robustness-feedback self-correct</a:t>
             </a:r>
@@ -4703,7 +4675,7 @@
         <p:spPr>
           <a:xfrm>
             <a:off x="5453640" y="3354120"/>
-            <a:ext cx="2007000" cy="179640"/>
+            <a:ext cx="2006640" cy="179280"/>
           </a:xfrm>
           <a:prstGeom prst="roundRect">
             <a:avLst>
@@ -4743,6 +4715,7 @@
                   <a:srgbClr val="16213a"/>
                 </a:solidFill>
                 <a:latin typeface="Times New Roman"/>
+                <a:ea typeface="DejaVu Sans"/>
               </a:rPr>
               <a:t>operator norm. →,↔ basis</a:t>
             </a:r>
@@ -4761,7 +4734,7 @@
         <p:spPr>
           <a:xfrm>
             <a:off x="5453640" y="3624120"/>
-            <a:ext cx="2007000" cy="179640"/>
+            <a:ext cx="2006640" cy="179280"/>
           </a:xfrm>
           <a:prstGeom prst="roundRect">
             <a:avLst>
@@ -4801,6 +4774,7 @@
                   <a:srgbClr val="16213a"/>
                 </a:solidFill>
                 <a:latin typeface="Times New Roman"/>
+                <a:ea typeface="DejaVu Sans"/>
               </a:rPr>
               <a:t>sensor-grounded G ¬unsafe</a:t>
             </a:r>
@@ -4848,7 +4822,7 @@
         <p:spPr>
           <a:xfrm>
             <a:off x="8669520" y="3354120"/>
-            <a:ext cx="2709720" cy="179640"/>
+            <a:ext cx="2709360" cy="179280"/>
           </a:xfrm>
           <a:prstGeom prst="roundRect">
             <a:avLst>
@@ -4888,6 +4862,7 @@
                   <a:srgbClr val="16213a"/>
                 </a:solidFill>
                 <a:latin typeface="Times New Roman"/>
+                <a:ea typeface="DejaVu Sans"/>
               </a:rPr>
               <a:t>nested-tree decomposition</a:t>
             </a:r>
@@ -4906,7 +4881,7 @@
         <p:spPr>
           <a:xfrm>
             <a:off x="8669520" y="3624120"/>
-            <a:ext cx="2709720" cy="179640"/>
+            <a:ext cx="2709360" cy="179280"/>
           </a:xfrm>
           <a:prstGeom prst="roundRect">
             <a:avLst>
@@ -4946,6 +4921,7 @@
                   <a:srgbClr val="16213a"/>
                 </a:solidFill>
                 <a:latin typeface="Times New Roman"/>
+                <a:ea typeface="DejaVu Sans"/>
               </a:rPr>
               <a:t>best-of-N guided sampling</a:t>
             </a:r>
@@ -4993,7 +4969,7 @@
         <p:spPr>
           <a:xfrm>
             <a:off x="785520" y="1281600"/>
-            <a:ext cx="819720" cy="1179720"/>
+            <a:ext cx="819360" cy="1179360"/>
           </a:xfrm>
           <a:prstGeom prst="roundRect">
             <a:avLst>
@@ -5026,7 +5002,7 @@
         <p:spPr>
           <a:xfrm>
             <a:off x="845640" y="1431360"/>
-            <a:ext cx="699480" cy="819720"/>
+            <a:ext cx="699120" cy="819360"/>
           </a:xfrm>
           <a:prstGeom prst="rect">
             <a:avLst/>
@@ -5057,7 +5033,7 @@
         <p:spPr>
           <a:xfrm>
             <a:off x="1105560" y="1341360"/>
-            <a:ext cx="179640" cy="39600"/>
+            <a:ext cx="179280" cy="39240"/>
           </a:xfrm>
           <a:prstGeom prst="roundRect">
             <a:avLst>
@@ -5087,7 +5063,7 @@
         <p:spPr>
           <a:xfrm>
             <a:off x="1150560" y="2306520"/>
-            <a:ext cx="89640" cy="89640"/>
+            <a:ext cx="89280" cy="89280"/>
           </a:xfrm>
           <a:prstGeom prst="ellipse">
             <a:avLst/>
@@ -5115,7 +5091,7 @@
         <p:spPr>
           <a:xfrm>
             <a:off x="885600" y="1491480"/>
-            <a:ext cx="619560" cy="319680"/>
+            <a:ext cx="619200" cy="319320"/>
           </a:xfrm>
           <a:prstGeom prst="roundRect">
             <a:avLst>
@@ -5155,6 +5131,7 @@
                   <a:srgbClr val="33513a"/>
                 </a:solidFill>
                 <a:latin typeface="Times New Roman"/>
+                <a:ea typeface="DejaVu Sans"/>
               </a:rPr>
               <a:t>visit A,</a:t>
             </a:r>
@@ -5175,6 +5152,7 @@
                   <a:srgbClr val="33513a"/>
                 </a:solidFill>
                 <a:latin typeface="Times New Roman"/>
+                <a:ea typeface="DejaVu Sans"/>
               </a:rPr>
               <a:t>then B</a:t>
             </a:r>
@@ -5193,7 +5171,7 @@
         <p:spPr>
           <a:xfrm>
             <a:off x="885600" y="1851480"/>
-            <a:ext cx="619560" cy="329760"/>
+            <a:ext cx="619200" cy="329400"/>
           </a:xfrm>
           <a:prstGeom prst="roundRect">
             <a:avLst>
@@ -5233,6 +5211,7 @@
                   <a:srgbClr val="2c3e6b"/>
                 </a:solidFill>
                 <a:latin typeface="Times New Roman"/>
+                <a:ea typeface="DejaVu Sans"/>
               </a:rPr>
               <a:t>keep</a:t>
             </a:r>
@@ -5253,6 +5232,7 @@
                   <a:srgbClr val="2c3e6b"/>
                 </a:solidFill>
                 <a:latin typeface="Times New Roman"/>
+                <a:ea typeface="DejaVu Sans"/>
               </a:rPr>
               <a:t>safe</a:t>
             </a:r>
@@ -5271,7 +5251,7 @@
         <p:spPr>
           <a:xfrm>
             <a:off x="585360" y="2496600"/>
-            <a:ext cx="1219680" cy="229680"/>
+            <a:ext cx="1219320" cy="229320"/>
           </a:xfrm>
           <a:prstGeom prst="rect">
             <a:avLst/>
@@ -5304,6 +5284,7 @@
                   <a:srgbClr val="33513a"/>
                 </a:solidFill>
                 <a:latin typeface="Times New Roman"/>
+                <a:ea typeface="DejaVu Sans"/>
               </a:rPr>
               <a:t>Phone NL task</a:t>
             </a:r>
@@ -5322,7 +5303,7 @@
         <p:spPr>
           <a:xfrm>
             <a:off x="12485520" y="3328560"/>
-            <a:ext cx="1739520" cy="1699560"/>
+            <a:ext cx="1739160" cy="1699200"/>
           </a:xfrm>
           <a:prstGeom prst="roundRect">
             <a:avLst>
@@ -5355,7 +5336,7 @@
         <p:spPr>
           <a:xfrm>
             <a:off x="13225680" y="4128480"/>
-            <a:ext cx="279720" cy="279720"/>
+            <a:ext cx="279360" cy="279360"/>
           </a:xfrm>
           <a:prstGeom prst="ellipse">
             <a:avLst/>
@@ -5386,7 +5367,7 @@
         <p:spPr>
           <a:xfrm>
             <a:off x="12545640" y="3408480"/>
-            <a:ext cx="1619640" cy="1499760"/>
+            <a:ext cx="1619280" cy="1499400"/>
           </a:xfrm>
           <a:custGeom>
             <a:avLst/>
@@ -5435,7 +5416,7 @@
         <p:spPr>
           <a:xfrm>
             <a:off x="12615840" y="4698720"/>
-            <a:ext cx="99720" cy="99720"/>
+            <a:ext cx="99360" cy="99360"/>
           </a:xfrm>
           <a:prstGeom prst="ellipse">
             <a:avLst/>
@@ -5466,7 +5447,7 @@
         <p:spPr>
           <a:xfrm>
             <a:off x="13950720" y="3533400"/>
-            <a:ext cx="169560" cy="169560"/>
+            <a:ext cx="169200" cy="169200"/>
           </a:xfrm>
           <a:prstGeom prst="star5">
             <a:avLst>
@@ -5501,7 +5482,7 @@
         <p:spPr>
           <a:xfrm>
             <a:off x="13615560" y="3694320"/>
-            <a:ext cx="319680" cy="259560"/>
+            <a:ext cx="319320" cy="259200"/>
           </a:xfrm>
           <a:prstGeom prst="rect">
             <a:avLst/>
@@ -5534,6 +5515,7 @@
                   <a:srgbClr val="2e75b6"/>
                 </a:solidFill>
                 <a:latin typeface="Times New Roman"/>
+                <a:ea typeface="DejaVu Sans"/>
               </a:rPr>
               <a:t>τ</a:t>
             </a:r>
@@ -5552,7 +5534,7 @@
         <p:spPr>
           <a:xfrm>
             <a:off x="12477600" y="5043600"/>
-            <a:ext cx="1739520" cy="229680"/>
+            <a:ext cx="1739160" cy="229320"/>
           </a:xfrm>
           <a:prstGeom prst="rect">
             <a:avLst/>
@@ -5585,6 +5567,7 @@
                   <a:srgbClr val="7a4d1c"/>
                 </a:solidFill>
                 <a:latin typeface="Times New Roman"/>
+                <a:ea typeface="DejaVu Sans"/>
               </a:rPr>
               <a:t>Output trajectory τ</a:t>
             </a:r>
@@ -5602,7 +5585,7 @@
         </p:nvSpPr>
         <p:spPr>
           <a:xfrm>
-            <a:off x="5855400" y="1674360"/>
+            <a:off x="5120280" y="1674360"/>
             <a:ext cx="360" cy="336600"/>
           </a:xfrm>
           <a:prstGeom prst="line">
@@ -5636,7 +5619,7 @@
         <p:spPr>
           <a:xfrm>
             <a:off x="4112640" y="1104120"/>
-            <a:ext cx="449640" cy="449640"/>
+            <a:ext cx="449280" cy="449280"/>
           </a:xfrm>
           <a:prstGeom prst="rect">
             <a:avLst/>
@@ -5659,7 +5642,7 @@
         <p:spPr>
           <a:xfrm>
             <a:off x="6839280" y="1141920"/>
-            <a:ext cx="449640" cy="449640"/>
+            <a:ext cx="449280" cy="449280"/>
           </a:xfrm>
           <a:prstGeom prst="rect">
             <a:avLst/>
@@ -5682,7 +5665,7 @@
         <p:spPr>
           <a:xfrm>
             <a:off x="7220880" y="1137960"/>
-            <a:ext cx="449640" cy="449640"/>
+            <a:ext cx="449280" cy="449280"/>
           </a:xfrm>
           <a:prstGeom prst="rect">
             <a:avLst/>
@@ -5701,7 +5684,7 @@
         <p:spPr>
           <a:xfrm>
             <a:off x="2876760" y="1214640"/>
-            <a:ext cx="997920" cy="249480"/>
+            <a:ext cx="997560" cy="249480"/>
           </a:xfrm>
           <a:prstGeom prst="rect">
             <a:avLst/>
@@ -5734,6 +5717,7 @@
                   <a:srgbClr val="16213a"/>
                 </a:solidFill>
                 <a:latin typeface="Times New Roman"/>
+                <a:ea typeface="DejaVu Sans"/>
               </a:rPr>
               <a:t>Infrastructure</a:t>
             </a:r>
@@ -5752,7 +5736,7 @@
         <p:spPr>
           <a:xfrm>
             <a:off x="5180760" y="1214640"/>
-            <a:ext cx="1810080" cy="249480"/>
+            <a:ext cx="1809720" cy="249480"/>
           </a:xfrm>
           <a:prstGeom prst="rect">
             <a:avLst/>
@@ -5785,6 +5769,7 @@
                   <a:srgbClr val="16213a"/>
                 </a:solidFill>
                 <a:latin typeface="Times New Roman"/>
+                <a:ea typeface="DejaVu Sans"/>
               </a:rPr>
               <a:t>Other object / robot / human</a:t>
             </a:r>
@@ -5803,7 +5788,7 @@
         <p:spPr>
           <a:xfrm>
             <a:off x="11643480" y="2383920"/>
-            <a:ext cx="743400" cy="272160"/>
+            <a:ext cx="743040" cy="272160"/>
           </a:xfrm>
           <a:prstGeom prst="rect">
             <a:avLst/>
@@ -5836,6 +5821,7 @@
                   <a:srgbClr val="5b5b78"/>
                 </a:solidFill>
                 <a:latin typeface="Times New Roman"/>
+                <a:ea typeface="DejaVu Sans"/>
               </a:rPr>
               <a:t>Every 5s</a:t>
             </a:r>
@@ -5873,6 +5859,49 @@
           <a:effectRef idx="0"/>
           <a:fontRef idx="minor"/>
         </p:style>
+      </p:sp>
+      <p:sp>
+        <p:nvSpPr>
+          <p:cNvPr id="127" name=""/>
+          <p:cNvSpPr txBox="1"/>
+          <p:nvPr/>
+        </p:nvSpPr>
+        <p:spPr>
+          <a:xfrm>
+            <a:off x="3342240" y="1702800"/>
+            <a:ext cx="1814400" cy="259560"/>
+          </a:xfrm>
+          <a:prstGeom prst="rect">
+            <a:avLst/>
+          </a:prstGeom>
+          <a:noFill/>
+          <a:ln w="0">
+            <a:noFill/>
+          </a:ln>
+        </p:spPr>
+        <p:txBody>
+          <a:bodyPr lIns="90000" rIns="90000" tIns="45000" bIns="45000" anchor="t">
+            <a:noAutofit/>
+          </a:bodyPr>
+          <a:p>
+            <a:pPr algn="ctr">
+              <a:buNone/>
+            </a:pPr>
+            <a:r>
+              <a:rPr b="1" lang="en-US" sz="1200" spc="-1" strike="noStrike">
+                <a:solidFill>
+                  <a:srgbClr val="5b5b78"/>
+                </a:solidFill>
+                <a:latin typeface="Times New Roman"/>
+                <a:ea typeface="DejaVu Sans"/>
+              </a:rPr>
+              <a:t>Static Obstacle Modeling</a:t>
+            </a:r>
+            <a:endParaRPr b="0" lang="en-US" sz="1200" spc="-1" strike="noStrike">
+              <a:latin typeface="Arial"/>
+            </a:endParaRPr>
+          </a:p>
+        </p:txBody>
       </p:sp>
     </p:spTree>
   </p:cSld>

</xml_diff>

<commit_message>
Figure 1: add smart-device icons (smartwatch + speaker) by the phone; text phone->smart devices
The NL-task box now shows a smartwatch (left) and a smart speaker (right) flanking
the phone, matching the relabel to "Natural-language task (smart devices)" -- a
wearable/mobile/voice spread for ubiquitous input. Icons are clean flat-black
silhouettes (device_icons.py) inserted into pipeline_v2.pptx, re-exported at the
same exact crop (1144x436). Paper text "phone" -> "smart device(s)" with phone kept
as the example at the entry-point sentence. Body still <=4 pages (5 total, 0 undef).
</commit_message>
<xml_diff>
--- a/outputs/paper/pipeline_v2.pptx
+++ b/outputs/paper/pipeline_v2.pptx
@@ -1606,7 +1606,7 @@
         <p:spPr>
           <a:xfrm>
             <a:off x="2505600" y="2002680"/>
-            <a:ext cx="9291960" cy="2151000"/>
+            <a:ext cx="9291240" cy="2150280"/>
           </a:xfrm>
           <a:prstGeom prst="roundRect">
             <a:avLst>
@@ -1639,7 +1639,7 @@
         <p:spPr>
           <a:xfrm>
             <a:off x="8071920" y="675720"/>
-            <a:ext cx="6320880" cy="1005120"/>
+            <a:ext cx="6320160" cy="1004400"/>
           </a:xfrm>
           <a:prstGeom prst="roundRect">
             <a:avLst>
@@ -1672,7 +1672,7 @@
         <p:spPr>
           <a:xfrm>
             <a:off x="180720" y="669240"/>
-            <a:ext cx="1986120" cy="2682720"/>
+            <a:ext cx="1985400" cy="2682000"/>
           </a:xfrm>
           <a:prstGeom prst="roundRect">
             <a:avLst>
@@ -1705,7 +1705,7 @@
         <p:spPr>
           <a:xfrm>
             <a:off x="12304800" y="2011680"/>
-            <a:ext cx="2085840" cy="3490920"/>
+            <a:ext cx="2085120" cy="3490200"/>
           </a:xfrm>
           <a:prstGeom prst="roundRect">
             <a:avLst>
@@ -1738,7 +1738,7 @@
         <p:spPr>
           <a:xfrm>
             <a:off x="3604320" y="4489920"/>
-            <a:ext cx="4514760" cy="1005120"/>
+            <a:ext cx="4514040" cy="1004400"/>
           </a:xfrm>
           <a:prstGeom prst="roundRect">
             <a:avLst>
@@ -1771,7 +1771,7 @@
         <p:spPr>
           <a:xfrm>
             <a:off x="8556840" y="4482000"/>
-            <a:ext cx="3431160" cy="1005120"/>
+            <a:ext cx="3430440" cy="1004400"/>
           </a:xfrm>
           <a:prstGeom prst="roundRect">
             <a:avLst>
@@ -1804,7 +1804,7 @@
         <p:spPr>
           <a:xfrm>
             <a:off x="2709360" y="2095560"/>
-            <a:ext cx="2347200" cy="1089000"/>
+            <a:ext cx="2346480" cy="1088280"/>
           </a:xfrm>
           <a:prstGeom prst="roundRect">
             <a:avLst>
@@ -1894,7 +1894,7 @@
         <p:spPr>
           <a:xfrm>
             <a:off x="2664000" y="3285720"/>
-            <a:ext cx="2437560" cy="803880"/>
+            <a:ext cx="2436840" cy="803160"/>
           </a:xfrm>
           <a:prstGeom prst="roundRect">
             <a:avLst>
@@ -1927,7 +1927,7 @@
         <p:spPr>
           <a:xfrm>
             <a:off x="5418720" y="2095560"/>
-            <a:ext cx="2076480" cy="1089000"/>
+            <a:ext cx="2075760" cy="1088280"/>
           </a:xfrm>
           <a:prstGeom prst="roundRect">
             <a:avLst>
@@ -2007,7 +2007,7 @@
         <p:spPr>
           <a:xfrm>
             <a:off x="5373360" y="3285720"/>
-            <a:ext cx="2166840" cy="586080"/>
+            <a:ext cx="2166120" cy="585360"/>
           </a:xfrm>
           <a:prstGeom prst="roundRect">
             <a:avLst>
@@ -2040,7 +2040,7 @@
         <p:spPr>
           <a:xfrm>
             <a:off x="7857000" y="2095560"/>
-            <a:ext cx="3792240" cy="1089000"/>
+            <a:ext cx="3791520" cy="1088280"/>
           </a:xfrm>
           <a:prstGeom prst="roundRect">
             <a:avLst>
@@ -2073,7 +2073,7 @@
         <p:spPr>
           <a:xfrm>
             <a:off x="8037720" y="2522880"/>
-            <a:ext cx="857160" cy="443520"/>
+            <a:ext cx="856440" cy="442800"/>
           </a:xfrm>
           <a:prstGeom prst="roundRect">
             <a:avLst>
@@ -2153,7 +2153,7 @@
         <p:spPr>
           <a:xfrm>
             <a:off x="8579520" y="3285720"/>
-            <a:ext cx="2889360" cy="586080"/>
+            <a:ext cx="2888640" cy="585360"/>
           </a:xfrm>
           <a:prstGeom prst="roundRect">
             <a:avLst>
@@ -2186,7 +2186,7 @@
         <p:spPr>
           <a:xfrm>
             <a:off x="9211680" y="2581560"/>
-            <a:ext cx="360360" cy="334440"/>
+            <a:ext cx="359640" cy="333720"/>
           </a:xfrm>
           <a:prstGeom prst="ellipse">
             <a:avLst/>
@@ -2253,7 +2253,7 @@
         <p:spPr>
           <a:xfrm>
             <a:off x="9753480" y="2581560"/>
-            <a:ext cx="360360" cy="334440"/>
+            <a:ext cx="359640" cy="333720"/>
           </a:xfrm>
           <a:prstGeom prst="ellipse">
             <a:avLst/>
@@ -2320,7 +2320,7 @@
         <p:spPr>
           <a:xfrm>
             <a:off x="10295640" y="2581560"/>
-            <a:ext cx="360360" cy="334440"/>
+            <a:ext cx="359640" cy="333720"/>
           </a:xfrm>
           <a:prstGeom prst="ellipse">
             <a:avLst/>
@@ -2377,7 +2377,7 @@
         <p:spPr>
           <a:xfrm>
             <a:off x="10837440" y="2581560"/>
-            <a:ext cx="360360" cy="334440"/>
+            <a:ext cx="359640" cy="333720"/>
           </a:xfrm>
           <a:prstGeom prst="ellipse">
             <a:avLst/>
@@ -2444,7 +2444,7 @@
         <p:spPr>
           <a:xfrm>
             <a:off x="11212200" y="4746600"/>
-            <a:ext cx="586440" cy="543960"/>
+            <a:ext cx="585720" cy="543240"/>
           </a:xfrm>
           <a:prstGeom prst="roundRect">
             <a:avLst>
@@ -2909,7 +2909,7 @@
         <p:spPr>
           <a:xfrm>
             <a:off x="180720" y="123480"/>
-            <a:ext cx="14385600" cy="338760"/>
+            <a:ext cx="14384880" cy="338040"/>
           </a:xfrm>
           <a:prstGeom prst="rect">
             <a:avLst/>
@@ -2961,7 +2961,7 @@
         <p:spPr>
           <a:xfrm>
             <a:off x="4602600" y="1702800"/>
-            <a:ext cx="5119200" cy="284760"/>
+            <a:ext cx="5118480" cy="284040"/>
           </a:xfrm>
           <a:prstGeom prst="rect">
             <a:avLst/>
@@ -3013,7 +3013,7 @@
         <p:spPr>
           <a:xfrm>
             <a:off x="219960" y="740520"/>
-            <a:ext cx="1929600" cy="462960"/>
+            <a:ext cx="1928880" cy="462240"/>
           </a:xfrm>
           <a:prstGeom prst="rect">
             <a:avLst/>
@@ -3069,7 +3069,7 @@
                 <a:latin typeface="Times New Roman"/>
                 <a:ea typeface="DejaVu Sans"/>
               </a:rPr>
-              <a:t>task  (phone)</a:t>
+              <a:t>task  (smart devices)</a:t>
             </a:r>
             <a:endParaRPr b="0" lang="en-US" sz="1250" spc="-1" strike="noStrike">
               <a:latin typeface="Arial"/>
@@ -3086,7 +3086,7 @@
         <p:spPr>
           <a:xfrm>
             <a:off x="334440" y="2896560"/>
-            <a:ext cx="1678320" cy="385200"/>
+            <a:ext cx="1677600" cy="384480"/>
           </a:xfrm>
           <a:prstGeom prst="rect">
             <a:avLst/>
@@ -3169,7 +3169,7 @@
         <p:spPr>
           <a:xfrm>
             <a:off x="7891560" y="2161080"/>
-            <a:ext cx="3723480" cy="253800"/>
+            <a:ext cx="3722760" cy="253080"/>
           </a:xfrm>
           <a:prstGeom prst="rect">
             <a:avLst/>
@@ -3221,7 +3221,7 @@
         <p:spPr>
           <a:xfrm>
             <a:off x="8740800" y="2919600"/>
-            <a:ext cx="2908800" cy="224280"/>
+            <a:ext cx="2908080" cy="223560"/>
           </a:xfrm>
           <a:prstGeom prst="rect">
             <a:avLst/>
@@ -3273,7 +3273,7 @@
         <p:spPr>
           <a:xfrm>
             <a:off x="12879720" y="2295720"/>
-            <a:ext cx="882000" cy="269280"/>
+            <a:ext cx="881280" cy="268560"/>
           </a:xfrm>
           <a:prstGeom prst="rect">
             <a:avLst/>
@@ -3325,7 +3325,7 @@
         <p:spPr>
           <a:xfrm>
             <a:off x="12146040" y="2646360"/>
-            <a:ext cx="2348640" cy="540360"/>
+            <a:ext cx="2347920" cy="539640"/>
           </a:xfrm>
           <a:prstGeom prst="rect">
             <a:avLst/>
@@ -3419,7 +3419,7 @@
         <p:spPr>
           <a:xfrm>
             <a:off x="3780360" y="4132440"/>
-            <a:ext cx="2558160" cy="269280"/>
+            <a:ext cx="2557440" cy="268560"/>
           </a:xfrm>
           <a:prstGeom prst="rect">
             <a:avLst/>
@@ -3471,7 +3471,7 @@
         <p:spPr>
           <a:xfrm>
             <a:off x="3660480" y="4593240"/>
-            <a:ext cx="4402440" cy="245880"/>
+            <a:ext cx="4401720" cy="245160"/>
           </a:xfrm>
           <a:prstGeom prst="rect">
             <a:avLst/>
@@ -3523,7 +3523,7 @@
         <p:spPr>
           <a:xfrm>
             <a:off x="3321000" y="4998960"/>
-            <a:ext cx="5081400" cy="372960"/>
+            <a:ext cx="5080680" cy="372240"/>
           </a:xfrm>
           <a:prstGeom prst="rect">
             <a:avLst/>
@@ -3606,7 +3606,7 @@
         <p:spPr>
           <a:xfrm>
             <a:off x="9223920" y="4584960"/>
-            <a:ext cx="2097360" cy="245880"/>
+            <a:ext cx="2096640" cy="245160"/>
           </a:xfrm>
           <a:prstGeom prst="rect">
             <a:avLst/>
@@ -3658,7 +3658,7 @@
         <p:spPr>
           <a:xfrm>
             <a:off x="9130320" y="4991040"/>
-            <a:ext cx="2104200" cy="372960"/>
+            <a:ext cx="2103480" cy="372240"/>
           </a:xfrm>
           <a:prstGeom prst="rect">
             <a:avLst/>
@@ -3741,7 +3741,7 @@
         <p:spPr>
           <a:xfrm>
             <a:off x="11298240" y="4511880"/>
-            <a:ext cx="469440" cy="208800"/>
+            <a:ext cx="468720" cy="208080"/>
           </a:xfrm>
           <a:prstGeom prst="rect">
             <a:avLst/>
@@ -3793,7 +3793,7 @@
         <p:spPr>
           <a:xfrm>
             <a:off x="791280" y="4064760"/>
-            <a:ext cx="1487160" cy="503280"/>
+            <a:ext cx="1486440" cy="502560"/>
           </a:xfrm>
           <a:prstGeom prst="rect">
             <a:avLst/>
@@ -3887,7 +3887,7 @@
         <p:spPr>
           <a:xfrm>
             <a:off x="9187200" y="768240"/>
-            <a:ext cx="4012560" cy="253800"/>
+            <a:ext cx="4011840" cy="253080"/>
           </a:xfrm>
           <a:prstGeom prst="rect">
             <a:avLst/>
@@ -3939,7 +3939,7 @@
         <p:spPr>
           <a:xfrm>
             <a:off x="9086040" y="1740240"/>
-            <a:ext cx="781200" cy="214920"/>
+            <a:ext cx="780480" cy="214200"/>
           </a:xfrm>
           <a:prstGeom prst="rect">
             <a:avLst/>
@@ -3991,7 +3991,7 @@
         <p:spPr>
           <a:xfrm>
             <a:off x="2438280" y="676800"/>
-            <a:ext cx="5418000" cy="1005120"/>
+            <a:ext cx="5417280" cy="1004400"/>
           </a:xfrm>
           <a:prstGeom prst="roundRect">
             <a:avLst>
@@ -4024,7 +4024,7 @@
         <p:spPr>
           <a:xfrm>
             <a:off x="3149280" y="768240"/>
-            <a:ext cx="4012560" cy="253800"/>
+            <a:ext cx="4011840" cy="253080"/>
           </a:xfrm>
           <a:prstGeom prst="rect">
             <a:avLst/>
@@ -4076,7 +4076,7 @@
         <p:spPr>
           <a:xfrm>
             <a:off x="2558520" y="1080000"/>
-            <a:ext cx="2488680" cy="539280"/>
+            <a:ext cx="2487960" cy="538560"/>
           </a:xfrm>
           <a:prstGeom prst="roundRect">
             <a:avLst>
@@ -4109,7 +4109,7 @@
         <p:spPr>
           <a:xfrm>
             <a:off x="5180760" y="1080000"/>
-            <a:ext cx="2555640" cy="539280"/>
+            <a:ext cx="2554920" cy="538560"/>
           </a:xfrm>
           <a:prstGeom prst="roundRect">
             <a:avLst>
@@ -4142,7 +4142,7 @@
         <p:spPr>
           <a:xfrm>
             <a:off x="12477240" y="1074240"/>
-            <a:ext cx="1819440" cy="499320"/>
+            <a:ext cx="1818720" cy="498600"/>
           </a:xfrm>
           <a:prstGeom prst="roundRect">
             <a:avLst>
@@ -4222,7 +4222,7 @@
         <p:spPr>
           <a:xfrm>
             <a:off x="10321920" y="1074960"/>
-            <a:ext cx="1819440" cy="499320"/>
+            <a:ext cx="1818720" cy="498600"/>
           </a:xfrm>
           <a:prstGeom prst="roundRect">
             <a:avLst>
@@ -4302,7 +4302,7 @@
         <p:spPr>
           <a:xfrm>
             <a:off x="8166240" y="1074240"/>
-            <a:ext cx="1819440" cy="499320"/>
+            <a:ext cx="1818720" cy="498600"/>
           </a:xfrm>
           <a:prstGeom prst="roundRect">
             <a:avLst>
@@ -4440,7 +4440,7 @@
         <p:spPr>
           <a:xfrm>
             <a:off x="2754000" y="3327840"/>
-            <a:ext cx="2257560" cy="179280"/>
+            <a:ext cx="2256840" cy="178560"/>
           </a:xfrm>
           <a:prstGeom prst="roundRect">
             <a:avLst>
@@ -4499,7 +4499,7 @@
         <p:spPr>
           <a:xfrm>
             <a:off x="2754000" y="3597840"/>
-            <a:ext cx="2257560" cy="179280"/>
+            <a:ext cx="2256840" cy="178560"/>
           </a:xfrm>
           <a:prstGeom prst="roundRect">
             <a:avLst>
@@ -4558,7 +4558,7 @@
         <p:spPr>
           <a:xfrm>
             <a:off x="2754000" y="3867840"/>
-            <a:ext cx="2257560" cy="179280"/>
+            <a:ext cx="2256840" cy="178560"/>
           </a:xfrm>
           <a:prstGeom prst="roundRect">
             <a:avLst>
@@ -4675,7 +4675,7 @@
         <p:spPr>
           <a:xfrm>
             <a:off x="5453640" y="3354120"/>
-            <a:ext cx="2006640" cy="179280"/>
+            <a:ext cx="2005920" cy="178560"/>
           </a:xfrm>
           <a:prstGeom prst="roundRect">
             <a:avLst>
@@ -4734,7 +4734,7 @@
         <p:spPr>
           <a:xfrm>
             <a:off x="5453640" y="3624120"/>
-            <a:ext cx="2006640" cy="179280"/>
+            <a:ext cx="2005920" cy="178560"/>
           </a:xfrm>
           <a:prstGeom prst="roundRect">
             <a:avLst>
@@ -4822,7 +4822,7 @@
         <p:spPr>
           <a:xfrm>
             <a:off x="8669520" y="3354120"/>
-            <a:ext cx="2709360" cy="179280"/>
+            <a:ext cx="2708640" cy="178560"/>
           </a:xfrm>
           <a:prstGeom prst="roundRect">
             <a:avLst>
@@ -4881,7 +4881,7 @@
         <p:spPr>
           <a:xfrm>
             <a:off x="8669520" y="3624120"/>
-            <a:ext cx="2709360" cy="179280"/>
+            <a:ext cx="2708640" cy="178560"/>
           </a:xfrm>
           <a:prstGeom prst="roundRect">
             <a:avLst>
@@ -4969,7 +4969,7 @@
         <p:spPr>
           <a:xfrm>
             <a:off x="785520" y="1281600"/>
-            <a:ext cx="819360" cy="1179360"/>
+            <a:ext cx="818640" cy="1178640"/>
           </a:xfrm>
           <a:prstGeom prst="roundRect">
             <a:avLst>
@@ -5002,7 +5002,7 @@
         <p:spPr>
           <a:xfrm>
             <a:off x="845640" y="1431360"/>
-            <a:ext cx="699120" cy="819360"/>
+            <a:ext cx="698400" cy="818640"/>
           </a:xfrm>
           <a:prstGeom prst="rect">
             <a:avLst/>
@@ -5033,7 +5033,7 @@
         <p:spPr>
           <a:xfrm>
             <a:off x="1105560" y="1341360"/>
-            <a:ext cx="179280" cy="39240"/>
+            <a:ext cx="178560" cy="38520"/>
           </a:xfrm>
           <a:prstGeom prst="roundRect">
             <a:avLst>
@@ -5063,7 +5063,7 @@
         <p:spPr>
           <a:xfrm>
             <a:off x="1150560" y="2306520"/>
-            <a:ext cx="89280" cy="89280"/>
+            <a:ext cx="88560" cy="88560"/>
           </a:xfrm>
           <a:prstGeom prst="ellipse">
             <a:avLst/>
@@ -5091,7 +5091,7 @@
         <p:spPr>
           <a:xfrm>
             <a:off x="885600" y="1491480"/>
-            <a:ext cx="619200" cy="319320"/>
+            <a:ext cx="618480" cy="318600"/>
           </a:xfrm>
           <a:prstGeom prst="roundRect">
             <a:avLst>
@@ -5171,7 +5171,7 @@
         <p:spPr>
           <a:xfrm>
             <a:off x="885600" y="1851480"/>
-            <a:ext cx="619200" cy="329400"/>
+            <a:ext cx="618480" cy="328680"/>
           </a:xfrm>
           <a:prstGeom prst="roundRect">
             <a:avLst>
@@ -5251,7 +5251,7 @@
         <p:spPr>
           <a:xfrm>
             <a:off x="585360" y="2496600"/>
-            <a:ext cx="1219320" cy="229320"/>
+            <a:ext cx="1218600" cy="228600"/>
           </a:xfrm>
           <a:prstGeom prst="rect">
             <a:avLst/>
@@ -5286,7 +5286,17 @@
                 <a:latin typeface="Times New Roman"/>
                 <a:ea typeface="DejaVu Sans"/>
               </a:rPr>
-              <a:t>Phone NL task</a:t>
+              <a:t> </a:t>
+            </a:r>
+            <a:r>
+              <a:rPr b="1" lang="en-US" sz="1000" spc="-1" strike="noStrike">
+                <a:solidFill>
+                  <a:srgbClr val="33513a"/>
+                </a:solidFill>
+                <a:latin typeface="Times New Roman"/>
+                <a:ea typeface="DejaVu Sans"/>
+              </a:rPr>
+              <a:t>NL task</a:t>
             </a:r>
             <a:endParaRPr b="0" lang="en-US" sz="1000" spc="-1" strike="noStrike">
               <a:latin typeface="Arial"/>
@@ -5303,7 +5313,7 @@
         <p:spPr>
           <a:xfrm>
             <a:off x="12485520" y="3328560"/>
-            <a:ext cx="1739160" cy="1699200"/>
+            <a:ext cx="1738440" cy="1698480"/>
           </a:xfrm>
           <a:prstGeom prst="roundRect">
             <a:avLst>
@@ -5336,7 +5346,7 @@
         <p:spPr>
           <a:xfrm>
             <a:off x="13225680" y="4128480"/>
-            <a:ext cx="279360" cy="279360"/>
+            <a:ext cx="278640" cy="278640"/>
           </a:xfrm>
           <a:prstGeom prst="ellipse">
             <a:avLst/>
@@ -5367,7 +5377,7 @@
         <p:spPr>
           <a:xfrm>
             <a:off x="12545640" y="3408480"/>
-            <a:ext cx="1619280" cy="1499400"/>
+            <a:ext cx="1618560" cy="1498680"/>
           </a:xfrm>
           <a:custGeom>
             <a:avLst/>
@@ -5416,7 +5426,7 @@
         <p:spPr>
           <a:xfrm>
             <a:off x="12615840" y="4698720"/>
-            <a:ext cx="99360" cy="99360"/>
+            <a:ext cx="98640" cy="98640"/>
           </a:xfrm>
           <a:prstGeom prst="ellipse">
             <a:avLst/>
@@ -5447,7 +5457,7 @@
         <p:spPr>
           <a:xfrm>
             <a:off x="13950720" y="3533400"/>
-            <a:ext cx="169200" cy="169200"/>
+            <a:ext cx="168480" cy="168480"/>
           </a:xfrm>
           <a:prstGeom prst="star5">
             <a:avLst>
@@ -5482,7 +5492,7 @@
         <p:spPr>
           <a:xfrm>
             <a:off x="13615560" y="3694320"/>
-            <a:ext cx="319320" cy="259200"/>
+            <a:ext cx="318600" cy="258480"/>
           </a:xfrm>
           <a:prstGeom prst="rect">
             <a:avLst/>
@@ -5534,7 +5544,7 @@
         <p:spPr>
           <a:xfrm>
             <a:off x="12477600" y="5043600"/>
-            <a:ext cx="1739160" cy="229320"/>
+            <a:ext cx="1738440" cy="228600"/>
           </a:xfrm>
           <a:prstGeom prst="rect">
             <a:avLst/>
@@ -5619,7 +5629,7 @@
         <p:spPr>
           <a:xfrm>
             <a:off x="4112640" y="1104120"/>
-            <a:ext cx="449280" cy="449280"/>
+            <a:ext cx="448560" cy="448560"/>
           </a:xfrm>
           <a:prstGeom prst="rect">
             <a:avLst/>
@@ -5642,7 +5652,7 @@
         <p:spPr>
           <a:xfrm>
             <a:off x="6839280" y="1141920"/>
-            <a:ext cx="449280" cy="449280"/>
+            <a:ext cx="448560" cy="448560"/>
           </a:xfrm>
           <a:prstGeom prst="rect">
             <a:avLst/>
@@ -5665,7 +5675,7 @@
         <p:spPr>
           <a:xfrm>
             <a:off x="7220880" y="1137960"/>
-            <a:ext cx="449280" cy="449280"/>
+            <a:ext cx="448560" cy="448560"/>
           </a:xfrm>
           <a:prstGeom prst="rect">
             <a:avLst/>
@@ -5684,7 +5694,7 @@
         <p:spPr>
           <a:xfrm>
             <a:off x="2876760" y="1214640"/>
-            <a:ext cx="997560" cy="249480"/>
+            <a:ext cx="996840" cy="249480"/>
           </a:xfrm>
           <a:prstGeom prst="rect">
             <a:avLst/>
@@ -5736,7 +5746,7 @@
         <p:spPr>
           <a:xfrm>
             <a:off x="5180760" y="1214640"/>
-            <a:ext cx="1809720" cy="249480"/>
+            <a:ext cx="1809000" cy="249480"/>
           </a:xfrm>
           <a:prstGeom prst="rect">
             <a:avLst/>
@@ -5788,7 +5798,7 @@
         <p:spPr>
           <a:xfrm>
             <a:off x="11643480" y="2383920"/>
-            <a:ext cx="743040" cy="272160"/>
+            <a:ext cx="742320" cy="272160"/>
           </a:xfrm>
           <a:prstGeom prst="rect">
             <a:avLst/>
@@ -5863,13 +5873,13 @@
       <p:sp>
         <p:nvSpPr>
           <p:cNvPr id="127" name=""/>
-          <p:cNvSpPr txBox="1"/>
+          <p:cNvSpPr/>
           <p:nvPr/>
         </p:nvSpPr>
         <p:spPr>
           <a:xfrm>
             <a:off x="3342240" y="1702800"/>
-            <a:ext cx="1814400" cy="259560"/>
+            <a:ext cx="1813680" cy="258840"/>
           </a:xfrm>
           <a:prstGeom prst="rect">
             <a:avLst/>
@@ -5879,12 +5889,21 @@
             <a:noFill/>
           </a:ln>
         </p:spPr>
+        <p:style>
+          <a:lnRef idx="0"/>
+          <a:fillRef idx="0"/>
+          <a:effectRef idx="0"/>
+          <a:fontRef idx="minor"/>
+        </p:style>
         <p:txBody>
           <a:bodyPr lIns="90000" rIns="90000" tIns="45000" bIns="45000" anchor="t">
             <a:noAutofit/>
           </a:bodyPr>
           <a:p>
             <a:pPr algn="ctr">
+              <a:lnSpc>
+                <a:spcPct val="100000"/>
+              </a:lnSpc>
               <a:buNone/>
             </a:pPr>
             <a:r>
@@ -5903,6 +5922,52 @@
           </a:p>
         </p:txBody>
       </p:sp>
+      <p:pic>
+        <p:nvPicPr>
+          <p:cNvPr id="200" name="smartwatch" descr="smartwatch"/>
+          <p:cNvPicPr/>
+          <p:nvPr/>
+        </p:nvPicPr>
+        <p:blipFill>
+          <a:blip r:embed="rId5"/>
+          <a:stretch/>
+        </p:blipFill>
+        <p:spPr>
+          <a:xfrm>
+            <a:off x="254000" y="1638300"/>
+            <a:ext cx="457200" cy="457200"/>
+          </a:xfrm>
+          <a:prstGeom prst="rect">
+            <a:avLst/>
+          </a:prstGeom>
+          <a:ln w="0">
+            <a:noFill/>
+          </a:ln>
+        </p:spPr>
+      </p:pic>
+      <p:pic>
+        <p:nvPicPr>
+          <p:cNvPr id="201" name="smartspeaker" descr="smartspeaker"/>
+          <p:cNvPicPr/>
+          <p:nvPr/>
+        </p:nvPicPr>
+        <p:blipFill>
+          <a:blip r:embed="rId6"/>
+          <a:stretch/>
+        </p:blipFill>
+        <p:spPr>
+          <a:xfrm>
+            <a:off x="1651000" y="1638300"/>
+            <a:ext cx="457200" cy="457200"/>
+          </a:xfrm>
+          <a:prstGeom prst="rect">
+            <a:avLst/>
+          </a:prstGeom>
+          <a:ln w="0">
+            <a:noFill/>
+          </a:ln>
+        </p:spPr>
+      </p:pic>
     </p:spTree>
   </p:cSld>
   <mc:AlternateContent>

</xml_diff>